<commit_message>
docs: correct final submission claims
</commit_message>
<xml_diff>
--- a/submission/Aegis_Pitch_Deck.pptx
+++ b/submission/Aegis_Pitch_Deck.pptx
@@ -4406,7 +4406,7 @@
               </a:defRPr>
             </a:pPr>
             <a:r>
-              <a:t>Extracts 9 normalized 2D skeletal landmarks (wrists, shoulders, hips, ankles). Completely strips facial identity, skin color, and background.</a:t>
+              <a:t>Extracts 9 normalized 2D skeletal landmarks (wrists, shoulders, hips, ankles). Aegis does not perform face recognition, face identification, facial embeddings or biometric identity tracking. One coarse nose keypoint is used only for pose geometry.</a:t>
             </a:r>
           </a:p>
         </p:txBody>
@@ -5372,7 +5372,7 @@
                   <a:srgbClr val="F5F8FA"/>
                 </a:solidFill>
               </a:rPr>
-              <a:t>MediaPipe Pose Estimator (Active Provider: MediaPipe CPU)</a:t>
+              <a:t>MediaPipe Pose Estimator (Active Provider: MediaPipe CPU; QNN Planned)</a:t>
             </a:r>
           </a:p>
         </p:txBody>
@@ -5954,7 +5954,7 @@
               </a:defRPr>
             </a:pPr>
             <a:r>
-              <a:t>Heads-up display running at 960x540 featuring live FPS meter, inference latency counter, dynamic threat gauge, and pattern timeline.</a:t>
+              <a:t>Heads-up display running at 960x540. QNN Hexagon NPU execution is planned via ONNX/QNN pose adapter.</a:t>
             </a:r>
           </a:p>
         </p:txBody>
@@ -6263,7 +6263,7 @@
               </a:defRPr>
             </a:pPr>
             <a:r>
-              <a:t>Aegis explicitly does not analyze facial landmarks, extract biometric templates, or interface with facial databases. It is architecturally blind to human identity.</a:t>
+              <a:t>Aegis does not perform face recognition, face identification, facial embeddings or biometric identity tracking. One coarse nose keypoint is used only for pose geometry.</a:t>
             </a:r>
           </a:p>
         </p:txBody>
@@ -7061,7 +7061,7 @@
               </a:defRPr>
             </a:pPr>
             <a:r>
-              <a:t>Qualcomm Snapdragon Optimization &amp; NPU Deployment Path</a:t>
+              <a:t>Qualcomm Snapdragon Optimization &amp; NPU Deployment Path (Planned)</a:t>
             </a:r>
           </a:p>
         </p:txBody>
@@ -7476,7 +7476,7 @@
                   <a:srgbClr val="00E5FF"/>
                 </a:solidFill>
               </a:rPr>
-              <a:t>[STAGE 4: RUNTIME ADAPTATION]  </a:t>
+              <a:t>[STAGE 4: RUNTIME ADAPTATION (PLANNED)]  </a:t>
             </a:r>
             <a:r>
               <a:rPr b="1" sz="1100">
@@ -7484,7 +7484,7 @@
                   <a:srgbClr val="F5F8FA"/>
                 </a:solidFill>
               </a:rPr>
-              <a:t>ONNX Runtime QNN Provider</a:t>
+              <a:t>ONNX/QNN Pose-Estimator Adapter</a:t>
             </a:r>
           </a:p>
           <a:p>
@@ -7496,7 +7496,7 @@
               </a:defRPr>
             </a:pPr>
             <a:r>
-              <a:t>Integrate compiled ONNX assets via QNNExecutionProvider with Hexagon Tensor Processor delegates (QnnHtp.dll) behind SnapdragonSession.</a:t>
+              <a:t>Implement adapter that preprocesses frames, calls session.run(), converts outputs to normalized PoseFrame landmarks, and replaces MediaPipePoseEstimator via QNN.</a:t>
             </a:r>
           </a:p>
         </p:txBody>
@@ -7574,7 +7574,7 @@
                   <a:srgbClr val="00E5FF"/>
                 </a:solidFill>
               </a:rPr>
-              <a:t>[STAGE 5: RIGOROUS BENCHMARKING]  </a:t>
+              <a:t>[STAGE 5: RIGOROUS BENCHMARKING (PLANNED)]  </a:t>
             </a:r>
             <a:r>
               <a:rPr b="1" sz="1100">
@@ -7629,7 +7629,7 @@
               </a:defRPr>
             </a:pPr>
             <a:r>
-              <a:t>* Architectural Transparency Note: All QNN/NPU execution steps are documented as the planned optimization roadmap. Aegis currently executes and reports MediaPipe CPU.</a:t>
+              <a:t>* Architectural Transparency Note: Supplying AEGIS_MODEL_PATH does not connect model outputs to pose estimation. Runtime diagnostics only verify provider availability. MediaPipe CPU is the only currently verified active pose provider; QNN is planned.</a:t>
             </a:r>
           </a:p>
         </p:txBody>
@@ -7969,7 +7969,7 @@
               </a:defRPr>
             </a:pPr>
             <a:r>
-              <a:t>• Truthful Telemetry: HUD truthfully reports MediaPipe CPU provider without fabricating NPU metrics.</a:t>
+              <a:t>• Truthful Telemetry: HUD reports MediaPipe CPU. QNN NPU execution is planned via pose adapter.</a:t>
             </a:r>
           </a:p>
           <a:p>
@@ -8103,7 +8103,7 @@
               </a:defRPr>
             </a:pPr>
             <a:r>
-              <a:t>• QNN Pose Model Integration: Deploy Qualcomm AI Hub compiled YOLOv8-pose INT8 model to Hexagon NPU.</a:t>
+              <a:t>• QNN Pose Model Integration (Planned): Implement ONNX/QNN pose adapter replacing MediaPipe on Hexagon NPU.</a:t>
             </a:r>
           </a:p>
           <a:p>

</xml_diff>